<commit_message>
Finalizando apresentação e revisão dos slides
</commit_message>
<xml_diff>
--- a/Desafio Bradesco - Felipe Piva.pptx
+++ b/Desafio Bradesco - Felipe Piva.pptx
@@ -713,6 +713,56 @@
           <a:chExt cx="0" cy="0"/>
         </a:xfrm>
       </p:grpSpPr>
+      <p:sp>
+        <p:nvSpPr>
+          <p:cNvPr id="3" name="CaixaDeTexto 2">
+            <a:extLst>
+              <a:ext uri="{FF2B5EF4-FFF2-40B4-BE49-F238E27FC236}">
+                <a16:creationId xmlns:a16="http://schemas.microsoft.com/office/drawing/2014/main" id="{0B2AF771-2B8E-9584-C1EC-87FE618B1228}"/>
+              </a:ext>
+            </a:extLst>
+          </p:cNvPr>
+          <p:cNvSpPr txBox="1"/>
+          <p:nvPr userDrawn="1">
+            <p:extLst>
+              <p:ext uri="{1162E1C5-73C7-4A58-AE30-91384D911F3F}">
+                <p184:classification xmlns:p184="http://schemas.microsoft.com/office/powerpoint/2018/4/main" val="hdr"/>
+              </p:ext>
+            </p:extLst>
+          </p:nvPr>
+        </p:nvSpPr>
+        <p:spPr>
+          <a:xfrm>
+            <a:off x="63500" y="63500"/>
+            <a:ext cx="906463" cy="152400"/>
+          </a:xfrm>
+          <a:prstGeom prst="rect">
+            <a:avLst/>
+          </a:prstGeom>
+        </p:spPr>
+        <p:txBody>
+          <a:bodyPr horzOverflow="overflow" lIns="0" tIns="0" rIns="0" bIns="0">
+            <a:spAutoFit/>
+          </a:bodyPr>
+          <a:lstStyle/>
+          <a:p>
+            <a:pPr algn="l"/>
+            <a:r>
+              <a:rPr lang="pt-BR" sz="1000">
+                <a:solidFill>
+                  <a:srgbClr val="000000">
+                    <a:alpha val="50000"/>
+                  </a:srgbClr>
+                </a:solidFill>
+                <a:latin typeface="Calibri" panose="020F0502020204030204" pitchFamily="34" charset="0"/>
+                <a:ea typeface="Calibri" panose="020F0502020204030204" pitchFamily="34" charset="0"/>
+                <a:cs typeface="Calibri" panose="020F0502020204030204" pitchFamily="34" charset="0"/>
+              </a:rPr>
+              <a:t>General Business</a:t>
+            </a:r>
+          </a:p>
+        </p:txBody>
+      </p:sp>
     </p:spTree>
   </p:cSld>
   <p:clrMap bg1="lt1" tx1="dk1" bg2="lt2" tx2="dk2" accent1="accent1" accent2="accent2" accent3="accent3" accent4="accent4" accent5="accent5" accent6="accent6" hlink="hlink" folHlink="folHlink"/>
@@ -1006,8 +1056,8 @@
         </p:nvSpPr>
         <p:spPr>
           <a:xfrm>
-            <a:off x="0" y="0"/>
-            <a:ext cx="18288000" cy="10287000"/>
+            <a:off x="0" y="-73968"/>
+            <a:ext cx="18365724" cy="10360968"/>
           </a:xfrm>
           <a:prstGeom prst="rect">
             <a:avLst/>
@@ -1023,7 +1073,7 @@
           <a:bodyPr/>
           <a:lstStyle/>
           <a:p>
-            <a:endParaRPr lang="pt-BR"/>
+            <a:endParaRPr lang="pt-BR" dirty="0"/>
           </a:p>
         </p:txBody>
       </p:sp>
@@ -1066,50 +1116,6 @@
                 <a:cs typeface="IBM Plex Mono" pitchFamily="34" charset="-120"/>
               </a:rPr>
               <a:t>DESAFIO TÉCNICO · DATA ENGINEER</a:t>
-            </a:r>
-            <a:endParaRPr lang="en-US" sz="1800" dirty="0"/>
-          </a:p>
-        </p:txBody>
-      </p:sp>
-      <p:sp>
-        <p:nvSpPr>
-          <p:cNvPr id="4" name="Text 2"/>
-          <p:cNvSpPr/>
-          <p:nvPr/>
-        </p:nvSpPr>
-        <p:spPr>
-          <a:xfrm>
-            <a:off x="11000184" y="838200"/>
-            <a:ext cx="6564618" cy="369540"/>
-          </a:xfrm>
-          <a:prstGeom prst="rect">
-            <a:avLst/>
-          </a:prstGeom>
-          <a:noFill/>
-          <a:ln/>
-        </p:spPr>
-        <p:txBody>
-          <a:bodyPr wrap="square" lIns="25400" tIns="25400" rIns="25400" bIns="25400" rtlCol="0" anchor="t">
-            <a:normAutofit fontScale="92500" lnSpcReduction="20000"/>
-          </a:bodyPr>
-          <a:lstStyle/>
-          <a:p>
-            <a:pPr marL="0" indent="0" algn="l">
-              <a:lnSpc>
-                <a:spcPct val="145000"/>
-              </a:lnSpc>
-              <a:buNone/>
-            </a:pPr>
-            <a:r>
-              <a:rPr lang="en-US" sz="1800" kern="0" spc="144" dirty="0">
-                <a:solidFill>
-                  <a:srgbClr val="6B6F77"/>
-                </a:solidFill>
-                <a:latin typeface="IBM Plex Mono" pitchFamily="34" charset="0"/>
-                <a:ea typeface="IBM Plex Mono" pitchFamily="34" charset="-122"/>
-                <a:cs typeface="IBM Plex Mono" pitchFamily="34" charset="-120"/>
-              </a:rPr>
-              <a:t>HHAR · HETEROGENEITY ACTIVITY RECOGNITION</a:t>
             </a:r>
             <a:endParaRPr lang="en-US" sz="1800" dirty="0"/>
           </a:p>
@@ -1153,7 +1159,73 @@
                 <a:ea typeface="IBM Plex Sans" pitchFamily="34" charset="-122"/>
                 <a:cs typeface="IBM Plex Sans" pitchFamily="34" charset="-120"/>
               </a:rPr>
-              <a:t>ETL de sensores HHAR em </a:t>
+              <a:t>ETL de </a:t>
+            </a:r>
+            <a:r>
+              <a:rPr lang="en-US" sz="7200" b="1" kern="0" spc="-252" dirty="0" err="1">
+                <a:solidFill>
+                  <a:srgbClr val="15171A"/>
+                </a:solidFill>
+                <a:latin typeface="IBM Plex Sans" pitchFamily="34" charset="0"/>
+                <a:ea typeface="IBM Plex Sans" pitchFamily="34" charset="-122"/>
+                <a:cs typeface="IBM Plex Sans" pitchFamily="34" charset="-120"/>
+              </a:rPr>
+              <a:t>sensores</a:t>
+            </a:r>
+            <a:r>
+              <a:rPr lang="en-US" sz="7200" b="1" kern="0" spc="-252" dirty="0">
+                <a:solidFill>
+                  <a:srgbClr val="15171A"/>
+                </a:solidFill>
+                <a:latin typeface="IBM Plex Sans" pitchFamily="34" charset="0"/>
+                <a:ea typeface="IBM Plex Sans" pitchFamily="34" charset="-122"/>
+                <a:cs typeface="IBM Plex Sans" pitchFamily="34" charset="-120"/>
+              </a:rPr>
+              <a:t> </a:t>
+            </a:r>
+            <a:r>
+              <a:rPr lang="en-US" sz="7200" b="1" kern="0" spc="-252" dirty="0" err="1">
+                <a:solidFill>
+                  <a:srgbClr val="15171A"/>
+                </a:solidFill>
+                <a:latin typeface="IBM Plex Sans" pitchFamily="34" charset="0"/>
+                <a:ea typeface="IBM Plex Sans" pitchFamily="34" charset="-122"/>
+                <a:cs typeface="IBM Plex Sans" pitchFamily="34" charset="-120"/>
+              </a:rPr>
+              <a:t>desafio</a:t>
+            </a:r>
+            <a:r>
+              <a:rPr lang="en-US" sz="7200" b="1" kern="0" spc="-252" dirty="0">
+                <a:solidFill>
+                  <a:srgbClr val="15171A"/>
+                </a:solidFill>
+                <a:latin typeface="IBM Plex Sans" pitchFamily="34" charset="0"/>
+                <a:ea typeface="IBM Plex Sans" pitchFamily="34" charset="-122"/>
+                <a:cs typeface="IBM Plex Sans" pitchFamily="34" charset="-120"/>
+              </a:rPr>
+              <a:t> Bradesco </a:t>
+            </a:r>
+            <a:r>
+              <a:rPr lang="en-US" sz="7200" b="1" kern="0" spc="-252" dirty="0" err="1">
+                <a:solidFill>
+                  <a:srgbClr val="15171A"/>
+                </a:solidFill>
+                <a:latin typeface="IBM Plex Sans" pitchFamily="34" charset="0"/>
+                <a:ea typeface="IBM Plex Sans" pitchFamily="34" charset="-122"/>
+                <a:cs typeface="IBM Plex Sans" pitchFamily="34" charset="-120"/>
+              </a:rPr>
+              <a:t>em</a:t>
+            </a:r>
+            <a:r>
+              <a:rPr lang="en-US" sz="7200" b="1" kern="0" spc="-252" dirty="0">
+                <a:solidFill>
+                  <a:srgbClr val="15171A"/>
+                </a:solidFill>
+                <a:latin typeface="IBM Plex Sans" pitchFamily="34" charset="0"/>
+                <a:ea typeface="IBM Plex Sans" pitchFamily="34" charset="-122"/>
+                <a:cs typeface="IBM Plex Sans" pitchFamily="34" charset="-120"/>
+              </a:rPr>
+              <a:t> </a:t>
             </a:r>
             <a:r>
               <a:rPr lang="en-US" sz="7200" b="1" kern="0" spc="-252" dirty="0">
@@ -1930,15 +2002,14 @@
         </p:spPr>
         <p:txBody>
           <a:bodyPr wrap="square" lIns="25400" tIns="25400" rIns="25400" bIns="25400" rtlCol="0" anchor="t">
-            <a:normAutofit/>
-          </a:bodyPr>
-          <a:lstStyle/>
-          <a:p>
-            <a:pPr marL="0" indent="0" algn="l">
+            <a:normAutofit fontScale="92500" lnSpcReduction="20000"/>
+          </a:bodyPr>
+          <a:lstStyle/>
+          <a:p>
+            <a:pPr>
               <a:lnSpc>
                 <a:spcPct val="135000"/>
               </a:lnSpc>
-              <a:buNone/>
             </a:pPr>
             <a:r>
               <a:rPr lang="en-US" sz="1800" dirty="0">
@@ -1982,7 +2053,18 @@
                 <a:ea typeface="IBM Plex Mono" pitchFamily="34" charset="-122"/>
                 <a:cs typeface="IBM Plex Mono" pitchFamily="34" charset="-120"/>
               </a:rPr>
-              <a:t>Phones × {accel, gyro} + Watch × {accel, gyro}</a:t>
+              <a:t>Phones × {accel, gyro} + Watch × {accel, gyro} + </a:t>
+            </a:r>
+            <a:r>
+              <a:rPr lang="en-US" dirty="0" err="1">
+                <a:solidFill>
+                  <a:srgbClr val="3A3D44"/>
+                </a:solidFill>
+                <a:latin typeface="IBM Plex Mono" pitchFamily="34" charset="0"/>
+                <a:ea typeface="IBM Plex Mono" pitchFamily="34" charset="-122"/>
+                <a:cs typeface="IBM Plex Mono" pitchFamily="34" charset="-120"/>
+              </a:rPr>
+              <a:t>unionByName</a:t>
             </a:r>
             <a:endParaRPr lang="en-US" sz="1800" dirty="0"/>
           </a:p>
@@ -2215,7 +2297,7 @@
         </p:spPr>
         <p:txBody>
           <a:bodyPr wrap="square" lIns="25400" tIns="25400" rIns="25400" bIns="25400" rtlCol="0" anchor="t">
-            <a:normAutofit fontScale="92500" lnSpcReduction="20000"/>
+            <a:normAutofit/>
           </a:bodyPr>
           <a:lstStyle/>
           <a:p>
@@ -2226,18 +2308,7 @@
               <a:buNone/>
             </a:pPr>
             <a:r>
-              <a:rPr lang="en-US" sz="1800" dirty="0">
-                <a:solidFill>
-                  <a:srgbClr val="3A3D44"/>
-                </a:solidFill>
-                <a:latin typeface="IBM Plex Mono" pitchFamily="34" charset="0"/>
-                <a:ea typeface="IBM Plex Mono" pitchFamily="34" charset="-122"/>
-                <a:cs typeface="IBM Plex Mono" pitchFamily="34" charset="-120"/>
-              </a:rPr>
-              <a:t>unionByName </a:t>
-            </a:r>
-            <a:r>
-              <a:rPr lang="en-US" sz="1800" dirty="0">
+              <a:rPr lang="en-US" sz="1800" dirty="0" err="1">
                 <a:solidFill>
                   <a:srgbClr val="3A3D44"/>
                 </a:solidFill>
@@ -2245,18 +2316,73 @@
                 <a:ea typeface="IBM Plex Sans" pitchFamily="34" charset="-122"/>
                 <a:cs typeface="IBM Plex Sans" pitchFamily="34" charset="-120"/>
               </a:rPr>
-              <a:t>+ colunas de proveniência </a:t>
+              <a:t>Investigação</a:t>
             </a:r>
             <a:r>
               <a:rPr lang="en-US" sz="1800" dirty="0">
                 <a:solidFill>
-                  <a:srgbClr val="6B6F77"/>
-                </a:solidFill>
-                <a:latin typeface="IBM Plex Mono" pitchFamily="34" charset="0"/>
-                <a:ea typeface="IBM Plex Mono" pitchFamily="34" charset="-122"/>
-                <a:cs typeface="IBM Plex Mono" pitchFamily="34" charset="-120"/>
-              </a:rPr>
-              <a:t>device_type · sensor · source_file</a:t>
+                  <a:srgbClr val="3A3D44"/>
+                </a:solidFill>
+                <a:latin typeface="IBM Plex Sans" pitchFamily="34" charset="0"/>
+                <a:ea typeface="IBM Plex Sans" pitchFamily="34" charset="-122"/>
+                <a:cs typeface="IBM Plex Sans" pitchFamily="34" charset="-120"/>
+              </a:rPr>
+              <a:t> de </a:t>
+            </a:r>
+            <a:r>
+              <a:rPr lang="en-US" sz="1800" dirty="0" err="1">
+                <a:solidFill>
+                  <a:srgbClr val="3A3D44"/>
+                </a:solidFill>
+                <a:latin typeface="IBM Plex Sans" pitchFamily="34" charset="0"/>
+                <a:ea typeface="IBM Plex Sans" pitchFamily="34" charset="-122"/>
+                <a:cs typeface="IBM Plex Sans" pitchFamily="34" charset="-120"/>
+              </a:rPr>
+              <a:t>problemas</a:t>
+            </a:r>
+            <a:r>
+              <a:rPr lang="en-US" sz="1800" dirty="0">
+                <a:solidFill>
+                  <a:srgbClr val="3A3D44"/>
+                </a:solidFill>
+                <a:latin typeface="IBM Plex Sans" pitchFamily="34" charset="0"/>
+                <a:ea typeface="IBM Plex Sans" pitchFamily="34" charset="-122"/>
+                <a:cs typeface="IBM Plex Sans" pitchFamily="34" charset="-120"/>
+              </a:rPr>
+              <a:t> e </a:t>
+            </a:r>
+            <a:r>
+              <a:rPr lang="en-US" sz="1800" dirty="0" err="1">
+                <a:solidFill>
+                  <a:srgbClr val="3A3D44"/>
+                </a:solidFill>
+                <a:latin typeface="IBM Plex Sans" pitchFamily="34" charset="0"/>
+                <a:ea typeface="IBM Plex Sans" pitchFamily="34" charset="-122"/>
+                <a:cs typeface="IBM Plex Sans" pitchFamily="34" charset="-120"/>
+              </a:rPr>
+              <a:t>soluções</a:t>
+            </a:r>
+            <a:r>
+              <a:rPr lang="en-US" sz="1800" dirty="0">
+                <a:solidFill>
+                  <a:srgbClr val="3A3D44"/>
+                </a:solidFill>
+                <a:latin typeface="IBM Plex Sans" pitchFamily="34" charset="0"/>
+                <a:ea typeface="IBM Plex Sans" pitchFamily="34" charset="-122"/>
+                <a:cs typeface="IBM Plex Sans" pitchFamily="34" charset="-120"/>
+              </a:rPr>
+              <a:t> </a:t>
+            </a:r>
+            <a:r>
+              <a:rPr lang="en-US" sz="1800" dirty="0" err="1">
+                <a:solidFill>
+                  <a:srgbClr val="3A3D44"/>
+                </a:solidFill>
+                <a:latin typeface="IBM Plex Sans" pitchFamily="34" charset="0"/>
+                <a:ea typeface="IBM Plex Sans" pitchFamily="34" charset="-122"/>
+                <a:cs typeface="IBM Plex Sans" pitchFamily="34" charset="-120"/>
+              </a:rPr>
+              <a:t>possíveis</a:t>
             </a:r>
             <a:endParaRPr lang="en-US" sz="1800" dirty="0"/>
           </a:p>
@@ -2797,7 +2923,7 @@
               <a:buNone/>
             </a:pPr>
             <a:r>
-              <a:rPr lang="en-US" sz="2100" b="1" dirty="0">
+              <a:rPr lang="en-US" sz="2100" b="1" dirty="0" err="1">
                 <a:solidFill>
                   <a:srgbClr val="15171A"/>
                 </a:solidFill>
@@ -2805,7 +2931,18 @@
                 <a:ea typeface="IBM Plex Sans" pitchFamily="34" charset="-122"/>
                 <a:cs typeface="IBM Plex Sans" pitchFamily="34" charset="-120"/>
               </a:rPr>
-              <a:t>Proveniência desde a ingestão </a:t>
+              <a:t>Rastreabilidade</a:t>
+            </a:r>
+            <a:r>
+              <a:rPr lang="en-US" sz="2100" b="1" dirty="0">
+                <a:solidFill>
+                  <a:srgbClr val="15171A"/>
+                </a:solidFill>
+                <a:latin typeface="IBM Plex Sans" pitchFamily="34" charset="0"/>
+                <a:ea typeface="IBM Plex Sans" pitchFamily="34" charset="-122"/>
+                <a:cs typeface="IBM Plex Sans" pitchFamily="34" charset="-120"/>
+              </a:rPr>
+              <a:t> desde a ingestão </a:t>
             </a:r>
             <a:r>
               <a:rPr lang="en-US" sz="2100" dirty="0">
@@ -2903,7 +3040,7 @@
         </p:nvSpPr>
         <p:spPr>
           <a:xfrm>
-            <a:off x="10058251" y="7703790"/>
+            <a:off x="10172551" y="7703790"/>
             <a:ext cx="7010400" cy="1584722"/>
           </a:xfrm>
           <a:prstGeom prst="roundRect">
@@ -2932,8 +3069,8 @@
         </p:nvSpPr>
         <p:spPr>
           <a:xfrm>
-            <a:off x="10172551" y="8027640"/>
-            <a:ext cx="6992112" cy="1584722"/>
+            <a:off x="10172551" y="7743974"/>
+            <a:ext cx="6896100" cy="1544538"/>
           </a:xfrm>
           <a:prstGeom prst="rect">
             <a:avLst/>
@@ -2943,11 +3080,11 @@
         </p:spPr>
         <p:txBody>
           <a:bodyPr wrap="square" lIns="25400" tIns="25400" rIns="25400" bIns="25400" rtlCol="0" anchor="t">
-            <a:normAutofit fontScale="92500"/>
-          </a:bodyPr>
-          <a:lstStyle/>
-          <a:p>
-            <a:pPr marL="0" indent="0" algn="l">
+            <a:normAutofit fontScale="92500" lnSpcReduction="20000"/>
+          </a:bodyPr>
+          <a:lstStyle/>
+          <a:p>
+            <a:pPr marL="0" indent="0" algn="ctr">
               <a:lnSpc>
                 <a:spcPct val="145000"/>
               </a:lnSpc>
@@ -2964,6 +3101,14 @@
               </a:rPr>
               <a:t> 33.741.500 </a:t>
             </a:r>
+          </a:p>
+          <a:p>
+            <a:pPr marL="0" indent="0" algn="ctr">
+              <a:lnSpc>
+                <a:spcPct val="145000"/>
+              </a:lnSpc>
+              <a:buNone/>
+            </a:pPr>
             <a:r>
               <a:rPr lang="en-US" sz="4200" kern="0" spc="84" dirty="0" err="1">
                 <a:solidFill>
@@ -3246,29 +3391,18 @@
               <a:buNone/>
             </a:pPr>
             <a:r>
-              <a:rPr lang="en-US" sz="1950" b="1" kern="0" spc="-19" dirty="0" err="1">
-                <a:solidFill>
-                  <a:srgbClr val="15171A"/>
-                </a:solidFill>
-                <a:latin typeface="IBM Plex Mono" pitchFamily="34" charset="0"/>
-                <a:ea typeface="IBM Plex Mono" pitchFamily="34" charset="-122"/>
-                <a:cs typeface="IBM Plex Mono" pitchFamily="34" charset="-120"/>
-              </a:rPr>
-              <a:t>gt</a:t>
-            </a:r>
-            <a:r>
-              <a:rPr lang="en-US" sz="1950" b="1" kern="0" spc="-19" dirty="0">
-                <a:solidFill>
-                  <a:srgbClr val="15171A"/>
-                </a:solidFill>
-                <a:latin typeface="IBM Plex Mono" pitchFamily="34" charset="0"/>
-                <a:ea typeface="IBM Plex Mono" pitchFamily="34" charset="-122"/>
-                <a:cs typeface="IBM Plex Mono" pitchFamily="34" charset="-120"/>
-              </a:rPr>
-              <a:t> </a:t>
-            </a:r>
-            <a:r>
-              <a:rPr lang="en-US" sz="1950" b="1" kern="0" spc="-19" dirty="0" err="1">
+              <a:rPr lang="en-US" sz="1950" kern="0" spc="-19" dirty="0">
+                <a:solidFill>
+                  <a:srgbClr val="15171A"/>
+                </a:solidFill>
+                <a:latin typeface="IBM Plex Mono" pitchFamily="34" charset="0"/>
+                <a:ea typeface="IBM Plex Mono" pitchFamily="34" charset="-122"/>
+                <a:cs typeface="IBM Plex Mono" pitchFamily="34" charset="-120"/>
+              </a:rPr>
+              <a:t>Gt </a:t>
+            </a:r>
+            <a:r>
+              <a:rPr lang="en-US" sz="1950" kern="0" spc="-19" dirty="0" err="1">
                 <a:solidFill>
                   <a:srgbClr val="15171A"/>
                 </a:solidFill>
@@ -3279,7 +3413,7 @@
               <a:t>registra</a:t>
             </a:r>
             <a:r>
-              <a:rPr lang="en-US" sz="1950" b="1" kern="0" spc="-19" dirty="0">
+              <a:rPr lang="en-US" sz="1950" kern="0" spc="-19" dirty="0">
                 <a:solidFill>
                   <a:srgbClr val="15171A"/>
                 </a:solidFill>
@@ -3290,7 +3424,7 @@
               <a:t> nulos reais com a string literal </a:t>
             </a:r>
             <a:r>
-              <a:rPr lang="en-US" sz="1950" b="1" kern="0" spc="-19" dirty="0">
+              <a:rPr lang="en-US" sz="1950" kern="0" spc="-19" dirty="0">
                 <a:solidFill>
                   <a:srgbClr val="15171A"/>
                 </a:solidFill>
@@ -3400,7 +3534,7 @@
           </a:bodyPr>
           <a:lstStyle/>
           <a:p>
-            <a:pPr>
+            <a:pPr algn="ctr">
               <a:lnSpc>
                 <a:spcPct val="150000"/>
               </a:lnSpc>
@@ -3651,7 +3785,7 @@
                 <a:ea typeface="IBM Plex Mono" pitchFamily="34" charset="-122"/>
                 <a:cs typeface="IBM Plex Mono" pitchFamily="34" charset="-120"/>
               </a:rPr>
-              <a:t>PROBLEMA 02 · UNIDADE DE TEMPO</a:t>
+              <a:t>PROBLEMA 02 ·QUALIDADE DO CREATION_TIME</a:t>
             </a:r>
             <a:endParaRPr lang="en-US" sz="1800" dirty="0"/>
           </a:p>
@@ -3666,7 +3800,7 @@
         <p:spPr>
           <a:xfrm>
             <a:off x="9525000" y="2815530"/>
-            <a:ext cx="7799546" cy="335161"/>
+            <a:ext cx="8124824" cy="335161"/>
           </a:xfrm>
           <a:prstGeom prst="rect">
             <a:avLst/>
@@ -3676,7 +3810,7 @@
         </p:spPr>
         <p:txBody>
           <a:bodyPr wrap="square" lIns="25400" tIns="25400" rIns="25400" bIns="25400" rtlCol="0" anchor="t">
-            <a:normAutofit fontScale="92500" lnSpcReduction="20000"/>
+            <a:normAutofit fontScale="77500" lnSpcReduction="20000"/>
           </a:bodyPr>
           <a:lstStyle/>
           <a:p>
@@ -3687,7 +3821,7 @@
               <a:buNone/>
             </a:pPr>
             <a:r>
-              <a:rPr lang="en-US" sz="1950" b="1" kern="0" spc="-19" dirty="0" err="1">
+              <a:rPr lang="en-US" sz="1950" kern="0" spc="-19" dirty="0" err="1">
                 <a:solidFill>
                   <a:srgbClr val="15171A"/>
                 </a:solidFill>
@@ -3698,7 +3832,7 @@
               <a:t>Qualidade</a:t>
             </a:r>
             <a:r>
-              <a:rPr lang="en-US" sz="1950" b="1" kern="0" spc="-19" dirty="0">
+              <a:rPr lang="en-US" sz="1950" kern="0" spc="-19" dirty="0">
                 <a:solidFill>
                   <a:srgbClr val="15171A"/>
                 </a:solidFill>
@@ -3709,7 +3843,7 @@
               <a:t> de </a:t>
             </a:r>
             <a:r>
-              <a:rPr lang="en-US" sz="1950" b="1" kern="0" spc="-19" dirty="0" err="1">
+              <a:rPr lang="en-US" sz="1950" kern="0" spc="-19" dirty="0" err="1">
                 <a:solidFill>
                   <a:srgbClr val="15171A"/>
                 </a:solidFill>
@@ -3720,7 +3854,7 @@
               <a:t>Creation_Time</a:t>
             </a:r>
             <a:r>
-              <a:rPr lang="en-US" sz="1950" b="1" kern="0" spc="-19" dirty="0">
+              <a:rPr lang="en-US" sz="1950" kern="0" spc="-19" dirty="0">
                 <a:solidFill>
                   <a:srgbClr val="15171A"/>
                 </a:solidFill>
@@ -3731,7 +3865,7 @@
               <a:t> n</a:t>
             </a:r>
             <a:r>
-              <a:rPr lang="pt-BR" sz="1950" b="1" kern="0" spc="-19" dirty="0" err="1">
+              <a:rPr lang="pt-BR" sz="1950" kern="0" spc="-19" dirty="0" err="1">
                 <a:solidFill>
                   <a:srgbClr val="15171A"/>
                 </a:solidFill>
@@ -3742,15 +3876,15 @@
               <a:t>ão</a:t>
             </a:r>
             <a:r>
-              <a:rPr lang="pt-BR" sz="1950" b="1" kern="0" spc="-19" dirty="0">
-                <a:solidFill>
-                  <a:srgbClr val="15171A"/>
-                </a:solidFill>
-                <a:latin typeface="IBM Plex Mono" pitchFamily="34" charset="0"/>
-                <a:ea typeface="IBM Plex Mono" pitchFamily="34" charset="-122"/>
-                <a:cs typeface="IBM Plex Mono" pitchFamily="34" charset="-120"/>
-              </a:rPr>
-              <a:t> confiável </a:t>
+              <a:rPr lang="pt-BR" sz="1950" kern="0" spc="-19" dirty="0">
+                <a:solidFill>
+                  <a:srgbClr val="15171A"/>
+                </a:solidFill>
+                <a:latin typeface="IBM Plex Mono" pitchFamily="34" charset="0"/>
+                <a:ea typeface="IBM Plex Mono" pitchFamily="34" charset="-122"/>
+                <a:cs typeface="IBM Plex Mono" pitchFamily="34" charset="-120"/>
+              </a:rPr>
+              <a:t> confiável  como referência temporal</a:t>
             </a:r>
             <a:endParaRPr lang="en-US" sz="1950" dirty="0"/>
           </a:p>
@@ -3775,7 +3909,7 @@
         </p:spPr>
         <p:txBody>
           <a:bodyPr wrap="square" lIns="25400" tIns="25400" rIns="25400" bIns="25400" rtlCol="0" anchor="t">
-            <a:normAutofit/>
+            <a:normAutofit fontScale="92500" lnSpcReduction="10000"/>
           </a:bodyPr>
           <a:lstStyle/>
           <a:p>
@@ -3824,7 +3958,7 @@
                 </a:solidFill>
                 <a:latin typeface="IBM Plex Mono" pitchFamily="34" charset="0"/>
               </a:rPr>
-              <a:t>a magnitude varia em 5 faixas de dígitos (12, 13, 14, 15, 19) </a:t>
+              <a:t>a magnitude varia em 5 faixas de dígitos (12, 13, 14, 15, 19), inclusive no mesmo device</a:t>
             </a:r>
             <a:endParaRPr lang="en-US" dirty="0">
               <a:solidFill>
@@ -3913,259 +4047,56 @@
               <a:t>— </a:t>
             </a:r>
             <a:r>
-              <a:rPr lang="en-US" sz="1800" dirty="0" err="1">
+              <a:rPr lang="pt-BR" dirty="0">
                 <a:solidFill>
                   <a:srgbClr val="15171A"/>
                 </a:solidFill>
                 <a:latin typeface="IBM Plex Sans" pitchFamily="34" charset="0"/>
-                <a:ea typeface="IBM Plex Sans" pitchFamily="34" charset="-122"/>
-                <a:cs typeface="IBM Plex Sans" pitchFamily="34" charset="-120"/>
-              </a:rPr>
-              <a:t>Testei</a:t>
-            </a:r>
-            <a:r>
-              <a:rPr lang="en-US" sz="1800" dirty="0">
+              </a:rPr>
+              <a:t>testei normalização por dígitos e rejeitei com evidência: alinhou a escala mas não o valor (81% seguiram com </a:t>
+            </a:r>
+            <a:r>
+              <a:rPr lang="pt-BR" dirty="0" err="1">
                 <a:solidFill>
                   <a:srgbClr val="15171A"/>
                 </a:solidFill>
                 <a:latin typeface="IBM Plex Sans" pitchFamily="34" charset="0"/>
-                <a:ea typeface="IBM Plex Sans" pitchFamily="34" charset="-122"/>
-                <a:cs typeface="IBM Plex Sans" pitchFamily="34" charset="-120"/>
-              </a:rPr>
-              <a:t> </a:t>
-            </a:r>
-            <a:r>
-              <a:rPr lang="en-US" sz="1800" dirty="0" err="1">
+              </a:rPr>
+              <a:t>Arrival</a:t>
+            </a:r>
+            <a:r>
+              <a:rPr lang="pt-BR" dirty="0">
                 <a:solidFill>
                   <a:srgbClr val="15171A"/>
                 </a:solidFill>
                 <a:latin typeface="IBM Plex Sans" pitchFamily="34" charset="0"/>
-                <a:ea typeface="IBM Plex Sans" pitchFamily="34" charset="-122"/>
-                <a:cs typeface="IBM Plex Sans" pitchFamily="34" charset="-120"/>
-              </a:rPr>
-              <a:t>normalizar</a:t>
-            </a:r>
-            <a:r>
-              <a:rPr lang="en-US" sz="1800" dirty="0">
+              </a:rPr>
+              <a:t> &lt; </a:t>
+            </a:r>
+            <a:r>
+              <a:rPr lang="pt-BR" dirty="0" err="1">
                 <a:solidFill>
                   <a:srgbClr val="15171A"/>
                 </a:solidFill>
                 <a:latin typeface="IBM Plex Sans" pitchFamily="34" charset="0"/>
-                <a:ea typeface="IBM Plex Sans" pitchFamily="34" charset="-122"/>
-                <a:cs typeface="IBM Plex Sans" pitchFamily="34" charset="-120"/>
-              </a:rPr>
-              <a:t> </a:t>
-            </a:r>
-            <a:r>
-              <a:rPr lang="en-US" sz="1800" dirty="0" err="1">
+              </a:rPr>
+              <a:t>Creation</a:t>
+            </a:r>
+            <a:r>
+              <a:rPr lang="pt-BR" dirty="0">
                 <a:solidFill>
                   <a:srgbClr val="15171A"/>
                 </a:solidFill>
                 <a:latin typeface="IBM Plex Sans" pitchFamily="34" charset="0"/>
-                <a:ea typeface="IBM Plex Sans" pitchFamily="34" charset="-122"/>
-                <a:cs typeface="IBM Plex Sans" pitchFamily="34" charset="-120"/>
-              </a:rPr>
-              <a:t>os</a:t>
-            </a:r>
-            <a:r>
-              <a:rPr lang="en-US" sz="1800" dirty="0">
-                <a:solidFill>
-                  <a:srgbClr val="15171A"/>
-                </a:solidFill>
-                <a:latin typeface="IBM Plex Sans" pitchFamily="34" charset="0"/>
-                <a:ea typeface="IBM Plex Sans" pitchFamily="34" charset="-122"/>
-                <a:cs typeface="IBM Plex Sans" pitchFamily="34" charset="-120"/>
-              </a:rPr>
-              <a:t> </a:t>
-            </a:r>
-            <a:r>
-              <a:rPr lang="en-US" sz="1800" dirty="0" err="1">
-                <a:solidFill>
-                  <a:srgbClr val="15171A"/>
-                </a:solidFill>
-                <a:latin typeface="IBM Plex Sans" pitchFamily="34" charset="0"/>
-                <a:ea typeface="IBM Plex Sans" pitchFamily="34" charset="-122"/>
-                <a:cs typeface="IBM Plex Sans" pitchFamily="34" charset="-120"/>
-              </a:rPr>
-              <a:t>digitos</a:t>
-            </a:r>
-            <a:r>
-              <a:rPr lang="en-US" sz="1800" dirty="0">
-                <a:solidFill>
-                  <a:srgbClr val="15171A"/>
-                </a:solidFill>
-                <a:latin typeface="IBM Plex Sans" pitchFamily="34" charset="0"/>
-                <a:ea typeface="IBM Plex Sans" pitchFamily="34" charset="-122"/>
-                <a:cs typeface="IBM Plex Sans" pitchFamily="34" charset="-120"/>
-              </a:rPr>
-              <a:t> mas </a:t>
-            </a:r>
-            <a:r>
-              <a:rPr lang="en-US" sz="1800" dirty="0" err="1">
-                <a:solidFill>
-                  <a:srgbClr val="15171A"/>
-                </a:solidFill>
-                <a:latin typeface="IBM Plex Sans" pitchFamily="34" charset="0"/>
-                <a:ea typeface="IBM Plex Sans" pitchFamily="34" charset="-122"/>
-                <a:cs typeface="IBM Plex Sans" pitchFamily="34" charset="-120"/>
-              </a:rPr>
-              <a:t>não</a:t>
-            </a:r>
-            <a:r>
-              <a:rPr lang="en-US" sz="1800" dirty="0">
-                <a:solidFill>
-                  <a:srgbClr val="15171A"/>
-                </a:solidFill>
-                <a:latin typeface="IBM Plex Sans" pitchFamily="34" charset="0"/>
-                <a:ea typeface="IBM Plex Sans" pitchFamily="34" charset="-122"/>
-                <a:cs typeface="IBM Plex Sans" pitchFamily="34" charset="-120"/>
-              </a:rPr>
-              <a:t> </a:t>
-            </a:r>
-            <a:r>
-              <a:rPr lang="en-US" sz="1800" dirty="0" err="1">
-                <a:solidFill>
-                  <a:srgbClr val="15171A"/>
-                </a:solidFill>
-                <a:latin typeface="IBM Plex Sans" pitchFamily="34" charset="0"/>
-                <a:ea typeface="IBM Plex Sans" pitchFamily="34" charset="-122"/>
-                <a:cs typeface="IBM Plex Sans" pitchFamily="34" charset="-120"/>
-              </a:rPr>
-              <a:t>tive</a:t>
-            </a:r>
-            <a:r>
-              <a:rPr lang="en-US" sz="1800" dirty="0">
-                <a:solidFill>
-                  <a:srgbClr val="15171A"/>
-                </a:solidFill>
-                <a:latin typeface="IBM Plex Sans" pitchFamily="34" charset="0"/>
-                <a:ea typeface="IBM Plex Sans" pitchFamily="34" charset="-122"/>
-                <a:cs typeface="IBM Plex Sans" pitchFamily="34" charset="-120"/>
-              </a:rPr>
-              <a:t> </a:t>
-            </a:r>
-            <a:r>
-              <a:rPr lang="en-US" sz="1800" dirty="0" err="1">
-                <a:solidFill>
-                  <a:srgbClr val="15171A"/>
-                </a:solidFill>
-                <a:latin typeface="IBM Plex Sans" pitchFamily="34" charset="0"/>
-                <a:ea typeface="IBM Plex Sans" pitchFamily="34" charset="-122"/>
-                <a:cs typeface="IBM Plex Sans" pitchFamily="34" charset="-120"/>
-              </a:rPr>
-              <a:t>sucesso</a:t>
-            </a:r>
-            <a:r>
-              <a:rPr lang="en-US" sz="1800" dirty="0">
-                <a:solidFill>
-                  <a:srgbClr val="15171A"/>
-                </a:solidFill>
-                <a:latin typeface="IBM Plex Sans" pitchFamily="34" charset="0"/>
-                <a:ea typeface="IBM Plex Sans" pitchFamily="34" charset="-122"/>
-                <a:cs typeface="IBM Plex Sans" pitchFamily="34" charset="-120"/>
-              </a:rPr>
-              <a:t> </a:t>
-            </a:r>
-            <a:r>
-              <a:rPr lang="en-US" sz="1800" dirty="0" err="1">
-                <a:solidFill>
-                  <a:srgbClr val="15171A"/>
-                </a:solidFill>
-                <a:latin typeface="IBM Plex Sans" pitchFamily="34" charset="0"/>
-                <a:ea typeface="IBM Plex Sans" pitchFamily="34" charset="-122"/>
-                <a:cs typeface="IBM Plex Sans" pitchFamily="34" charset="-120"/>
-              </a:rPr>
-              <a:t>devido</a:t>
-            </a:r>
-            <a:r>
-              <a:rPr lang="en-US" sz="1800" dirty="0">
-                <a:solidFill>
-                  <a:srgbClr val="15171A"/>
-                </a:solidFill>
-                <a:latin typeface="IBM Plex Sans" pitchFamily="34" charset="0"/>
-                <a:ea typeface="IBM Plex Sans" pitchFamily="34" charset="-122"/>
-                <a:cs typeface="IBM Plex Sans" pitchFamily="34" charset="-120"/>
-              </a:rPr>
-              <a:t> a </a:t>
-            </a:r>
-            <a:r>
-              <a:rPr lang="en-US" sz="1800" dirty="0" err="1">
-                <a:solidFill>
-                  <a:srgbClr val="15171A"/>
-                </a:solidFill>
-                <a:latin typeface="IBM Plex Sans" pitchFamily="34" charset="0"/>
-                <a:ea typeface="IBM Plex Sans" pitchFamily="34" charset="-122"/>
-                <a:cs typeface="IBM Plex Sans" pitchFamily="34" charset="-120"/>
-              </a:rPr>
-              <a:t>falta</a:t>
-            </a:r>
-            <a:r>
-              <a:rPr lang="en-US" sz="1800" dirty="0">
-                <a:solidFill>
-                  <a:srgbClr val="15171A"/>
-                </a:solidFill>
-                <a:latin typeface="IBM Plex Sans" pitchFamily="34" charset="0"/>
-                <a:ea typeface="IBM Plex Sans" pitchFamily="34" charset="-122"/>
-                <a:cs typeface="IBM Plex Sans" pitchFamily="34" charset="-120"/>
-              </a:rPr>
-              <a:t> de </a:t>
-            </a:r>
-            <a:r>
-              <a:rPr lang="en-US" sz="1800" dirty="0" err="1">
-                <a:solidFill>
-                  <a:srgbClr val="15171A"/>
-                </a:solidFill>
-                <a:latin typeface="IBM Plex Sans" pitchFamily="34" charset="0"/>
-                <a:ea typeface="IBM Plex Sans" pitchFamily="34" charset="-122"/>
-                <a:cs typeface="IBM Plex Sans" pitchFamily="34" charset="-120"/>
-              </a:rPr>
-              <a:t>padr</a:t>
-            </a:r>
-            <a:r>
-              <a:rPr lang="en-US" dirty="0" err="1">
-                <a:solidFill>
-                  <a:srgbClr val="15171A"/>
-                </a:solidFill>
-                <a:latin typeface="IBM Plex Sans" pitchFamily="34" charset="0"/>
-                <a:ea typeface="IBM Plex Sans" pitchFamily="34" charset="-122"/>
-                <a:cs typeface="IBM Plex Sans" pitchFamily="34" charset="-120"/>
-              </a:rPr>
-              <a:t>ão</a:t>
-            </a:r>
-            <a:r>
-              <a:rPr lang="en-US" dirty="0">
-                <a:solidFill>
-                  <a:srgbClr val="15171A"/>
-                </a:solidFill>
-                <a:latin typeface="IBM Plex Sans" pitchFamily="34" charset="0"/>
-                <a:ea typeface="IBM Plex Sans" pitchFamily="34" charset="-122"/>
-                <a:cs typeface="IBM Plex Sans" pitchFamily="34" charset="-120"/>
-              </a:rPr>
-              <a:t> entre as casas </a:t>
-            </a:r>
-            <a:r>
-              <a:rPr lang="en-US" dirty="0" err="1">
-                <a:solidFill>
-                  <a:srgbClr val="15171A"/>
-                </a:solidFill>
-                <a:latin typeface="IBM Plex Sans" pitchFamily="34" charset="0"/>
-                <a:ea typeface="IBM Plex Sans" pitchFamily="34" charset="-122"/>
-                <a:cs typeface="IBM Plex Sans" pitchFamily="34" charset="-120"/>
-              </a:rPr>
-              <a:t>decimais</a:t>
-            </a:r>
-            <a:r>
-              <a:rPr lang="en-US" dirty="0">
-                <a:solidFill>
-                  <a:srgbClr val="15171A"/>
-                </a:solidFill>
-                <a:latin typeface="IBM Plex Sans" pitchFamily="34" charset="0"/>
-                <a:ea typeface="IBM Plex Sans" pitchFamily="34" charset="-122"/>
-                <a:cs typeface="IBM Plex Sans" pitchFamily="34" charset="-120"/>
-              </a:rPr>
-              <a:t> </a:t>
-            </a:r>
-            <a:endParaRPr lang="en-US" sz="1800" dirty="0"/>
+              </a:rPr>
+              <a:t>).</a:t>
+            </a:r>
+            <a:endParaRPr lang="en-US" dirty="0">
+              <a:solidFill>
+                <a:srgbClr val="15171A"/>
+              </a:solidFill>
+              <a:latin typeface="IBM Plex Sans" pitchFamily="34" charset="0"/>
+            </a:endParaRPr>
           </a:p>
         </p:txBody>
       </p:sp>
@@ -4277,7 +4208,7 @@
               <a:buNone/>
             </a:pPr>
             <a:r>
-              <a:rPr lang="en-US" sz="1950" b="1" kern="0" spc="-19" dirty="0">
+              <a:rPr lang="en-US" sz="1950" kern="0" spc="-19" dirty="0">
                 <a:solidFill>
                   <a:srgbClr val="15171A"/>
                 </a:solidFill>
@@ -4288,7 +4219,7 @@
               <a:t>Duplicatas por </a:t>
             </a:r>
             <a:r>
-              <a:rPr lang="en-US" sz="1950" b="1" kern="0" spc="-19" dirty="0">
+              <a:rPr lang="en-US" sz="1950" kern="0" spc="-19" dirty="0">
                 <a:solidFill>
                   <a:srgbClr val="15171A"/>
                 </a:solidFill>
@@ -4299,7 +4230,7 @@
               <a:t>chave de negócio</a:t>
             </a:r>
             <a:r>
-              <a:rPr lang="en-US" sz="1950" b="1" kern="0" spc="-19" dirty="0">
+              <a:rPr lang="en-US" sz="1950" kern="0" spc="-19" dirty="0">
                 <a:solidFill>
                   <a:srgbClr val="15171A"/>
                 </a:solidFill>
@@ -4497,7 +4428,7 @@
           </a:bodyPr>
           <a:lstStyle/>
           <a:p>
-            <a:pPr>
+            <a:pPr algn="ctr">
               <a:lnSpc>
                 <a:spcPct val="150000"/>
               </a:lnSpc>
@@ -4645,7 +4576,7 @@
         </p:nvSpPr>
         <p:spPr>
           <a:xfrm>
-            <a:off x="9248775" y="6133802"/>
+            <a:off x="9273141" y="6085210"/>
             <a:ext cx="8124825" cy="3773537"/>
           </a:xfrm>
           <a:prstGeom prst="roundRect">
@@ -4793,15 +4724,14 @@
         </p:spPr>
         <p:txBody>
           <a:bodyPr wrap="square" lIns="25400" tIns="25400" rIns="25400" bIns="25400" rtlCol="0" anchor="t">
-            <a:normAutofit fontScale="92500" lnSpcReduction="20000"/>
-          </a:bodyPr>
-          <a:lstStyle/>
-          <a:p>
-            <a:pPr marL="0" indent="0" algn="l">
+            <a:normAutofit fontScale="92500" lnSpcReduction="10000"/>
+          </a:bodyPr>
+          <a:lstStyle/>
+          <a:p>
+            <a:pPr>
               <a:lnSpc>
                 <a:spcPct val="145000"/>
               </a:lnSpc>
-              <a:buNone/>
             </a:pPr>
             <a:r>
               <a:rPr lang="en-US" sz="1800" kern="0" spc="144" dirty="0">
@@ -4812,9 +4742,41 @@
                 <a:ea typeface="IBM Plex Mono" pitchFamily="34" charset="-122"/>
                 <a:cs typeface="IBM Plex Mono" pitchFamily="34" charset="-120"/>
               </a:rPr>
-              <a:t>PROBLEMA 04 · SINCRONIZAÇÃO</a:t>
-            </a:r>
-            <a:endParaRPr lang="en-US" sz="1800" dirty="0"/>
+              <a:t>PROBLEMA 04 · SINCRONIZAÇÃO </a:t>
+            </a:r>
+            <a:r>
+              <a:rPr lang="pt-BR" kern="0" spc="144" dirty="0" err="1">
+                <a:solidFill>
+                  <a:srgbClr val="B8651A"/>
+                </a:solidFill>
+                <a:latin typeface="IBM Plex Mono" pitchFamily="34" charset="0"/>
+              </a:rPr>
+              <a:t>Arrival</a:t>
+            </a:r>
+            <a:r>
+              <a:rPr lang="pt-BR" kern="0" spc="144" dirty="0">
+                <a:solidFill>
+                  <a:srgbClr val="B8651A"/>
+                </a:solidFill>
+                <a:latin typeface="IBM Plex Mono" pitchFamily="34" charset="0"/>
+              </a:rPr>
+              <a:t> &lt; </a:t>
+            </a:r>
+            <a:r>
+              <a:rPr lang="pt-BR" kern="0" spc="144" dirty="0" err="1">
+                <a:solidFill>
+                  <a:srgbClr val="B8651A"/>
+                </a:solidFill>
+                <a:latin typeface="IBM Plex Mono" pitchFamily="34" charset="0"/>
+              </a:rPr>
+              <a:t>Creation</a:t>
+            </a:r>
+            <a:endParaRPr lang="en-US" kern="0" spc="144" dirty="0">
+              <a:solidFill>
+                <a:srgbClr val="B8651A"/>
+              </a:solidFill>
+              <a:latin typeface="IBM Plex Mono" pitchFamily="34" charset="0"/>
+            </a:endParaRPr>
           </a:p>
         </p:txBody>
       </p:sp>
@@ -4837,39 +4799,95 @@
         </p:spPr>
         <p:txBody>
           <a:bodyPr wrap="square" lIns="25400" tIns="25400" rIns="25400" bIns="25400" rtlCol="0" anchor="t">
-            <a:normAutofit fontScale="92500" lnSpcReduction="20000"/>
-          </a:bodyPr>
-          <a:lstStyle/>
-          <a:p>
-            <a:pPr marL="0" indent="0" algn="l">
+            <a:normAutofit fontScale="85000" lnSpcReduction="10000"/>
+          </a:bodyPr>
+          <a:lstStyle/>
+          <a:p>
+            <a:pPr>
               <a:lnSpc>
                 <a:spcPct val="120000"/>
               </a:lnSpc>
-              <a:buNone/>
-            </a:pPr>
-            <a:r>
-              <a:rPr lang="en-US" sz="1950" b="1" kern="0" spc="-19" dirty="0">
-                <a:solidFill>
-                  <a:srgbClr val="15171A"/>
-                </a:solidFill>
-                <a:latin typeface="IBM Plex Mono" pitchFamily="34" charset="0"/>
-                <a:ea typeface="IBM Plex Mono" pitchFamily="34" charset="-122"/>
-                <a:cs typeface="IBM Plex Mono" pitchFamily="34" charset="-120"/>
-              </a:rPr>
-              <a:t>Arrival &lt; Creation </a:t>
-            </a:r>
-            <a:r>
-              <a:rPr lang="en-US" sz="1950" b="1" kern="0" spc="-19" dirty="0">
-                <a:solidFill>
-                  <a:srgbClr val="15171A"/>
-                </a:solidFill>
-                <a:latin typeface="IBM Plex Sans" pitchFamily="34" charset="0"/>
-                <a:ea typeface="IBM Plex Sans" pitchFamily="34" charset="-122"/>
-                <a:cs typeface="IBM Plex Sans" pitchFamily="34" charset="-120"/>
-              </a:rPr>
-              <a:t>— recebido antes de criado</a:t>
-            </a:r>
-            <a:endParaRPr lang="en-US" sz="1950" dirty="0"/>
+            </a:pPr>
+            <a:r>
+              <a:rPr lang="pt-BR" sz="2100" kern="0" spc="-19" dirty="0">
+                <a:solidFill>
+                  <a:srgbClr val="15171A"/>
+                </a:solidFill>
+                <a:latin typeface="IBM Plex Mono" pitchFamily="34" charset="0"/>
+              </a:rPr>
+              <a:t>não</a:t>
+            </a:r>
+            <a:r>
+              <a:rPr lang="pt-BR" sz="2000" dirty="0"/>
+              <a:t> </a:t>
+            </a:r>
+            <a:r>
+              <a:rPr lang="pt-BR" sz="2100" kern="0" spc="-19" dirty="0">
+                <a:solidFill>
+                  <a:srgbClr val="15171A"/>
+                </a:solidFill>
+                <a:latin typeface="IBM Plex Mono" pitchFamily="34" charset="0"/>
+              </a:rPr>
+              <a:t>prova</a:t>
+            </a:r>
+            <a:r>
+              <a:rPr lang="pt-BR" sz="2000" dirty="0"/>
+              <a:t> </a:t>
+            </a:r>
+            <a:r>
+              <a:rPr lang="pt-BR" sz="2100" kern="0" spc="-19" dirty="0">
+                <a:solidFill>
+                  <a:srgbClr val="15171A"/>
+                </a:solidFill>
+                <a:latin typeface="IBM Plex Mono" pitchFamily="34" charset="0"/>
+              </a:rPr>
+              <a:t>dessincronia</a:t>
+            </a:r>
+            <a:r>
+              <a:rPr lang="pt-BR" sz="2000" dirty="0"/>
+              <a:t> — </a:t>
+            </a:r>
+            <a:r>
+              <a:rPr lang="pt-BR" sz="2100" kern="0" spc="-19" dirty="0">
+                <a:solidFill>
+                  <a:srgbClr val="15171A"/>
+                </a:solidFill>
+                <a:latin typeface="IBM Plex Mono" pitchFamily="34" charset="0"/>
+              </a:rPr>
+              <a:t>prova</a:t>
+            </a:r>
+            <a:r>
+              <a:rPr lang="pt-BR" sz="2000" dirty="0"/>
+              <a:t> </a:t>
+            </a:r>
+            <a:r>
+              <a:rPr lang="pt-BR" sz="2100" kern="0" spc="-19" dirty="0">
+                <a:solidFill>
+                  <a:srgbClr val="15171A"/>
+                </a:solidFill>
+                <a:latin typeface="IBM Plex Mono" pitchFamily="34" charset="0"/>
+              </a:rPr>
+              <a:t>campo</a:t>
+            </a:r>
+            <a:r>
+              <a:rPr lang="pt-BR" sz="2000" dirty="0"/>
+              <a:t> </a:t>
+            </a:r>
+            <a:r>
+              <a:rPr lang="pt-BR" sz="2100" kern="0" spc="-19" dirty="0">
+                <a:solidFill>
+                  <a:srgbClr val="15171A"/>
+                </a:solidFill>
+                <a:latin typeface="IBM Plex Mono" pitchFamily="34" charset="0"/>
+              </a:rPr>
+              <a:t>podre</a:t>
+            </a:r>
+            <a:endParaRPr lang="en-US" sz="2100" kern="0" spc="-19" dirty="0">
+              <a:solidFill>
+                <a:srgbClr val="15171A"/>
+              </a:solidFill>
+              <a:latin typeface="IBM Plex Mono" pitchFamily="34" charset="0"/>
+            </a:endParaRPr>
           </a:p>
         </p:txBody>
       </p:sp>
@@ -4882,7 +4900,7 @@
         <p:spPr>
           <a:xfrm>
             <a:off x="9553575" y="7286179"/>
-            <a:ext cx="2408039" cy="342900"/>
+            <a:ext cx="3005137" cy="342900"/>
           </a:xfrm>
           <a:prstGeom prst="rect">
             <a:avLst/>
@@ -4903,6 +4921,17 @@
               <a:buNone/>
             </a:pPr>
             <a:r>
+              <a:rPr lang="en-US" sz="1800" dirty="0" err="1">
+                <a:solidFill>
+                  <a:srgbClr val="6B6F77"/>
+                </a:solidFill>
+                <a:latin typeface="IBM Plex Mono" pitchFamily="34" charset="0"/>
+                <a:ea typeface="IBM Plex Mono" pitchFamily="34" charset="-122"/>
+                <a:cs typeface="IBM Plex Mono" pitchFamily="34" charset="-120"/>
+              </a:rPr>
+              <a:t>Porcentagem</a:t>
+            </a:r>
+            <a:r>
               <a:rPr lang="en-US" sz="1800" dirty="0">
                 <a:solidFill>
                   <a:srgbClr val="6B6F77"/>
@@ -4911,7 +4940,29 @@
                 <a:ea typeface="IBM Plex Mono" pitchFamily="34" charset="-122"/>
                 <a:cs typeface="IBM Plex Mono" pitchFamily="34" charset="-120"/>
               </a:rPr>
-              <a:t>Devices afetados:</a:t>
+              <a:t> de </a:t>
+            </a:r>
+            <a:r>
+              <a:rPr lang="en-US" sz="1800" dirty="0" err="1">
+                <a:solidFill>
+                  <a:srgbClr val="6B6F77"/>
+                </a:solidFill>
+                <a:latin typeface="IBM Plex Mono" pitchFamily="34" charset="0"/>
+                <a:ea typeface="IBM Plex Mono" pitchFamily="34" charset="-122"/>
+                <a:cs typeface="IBM Plex Mono" pitchFamily="34" charset="-120"/>
+              </a:rPr>
+              <a:t>registros</a:t>
+            </a:r>
+            <a:r>
+              <a:rPr lang="en-US" sz="1800" dirty="0">
+                <a:solidFill>
+                  <a:srgbClr val="6B6F77"/>
+                </a:solidFill>
+                <a:latin typeface="IBM Plex Mono" pitchFamily="34" charset="0"/>
+                <a:ea typeface="IBM Plex Mono" pitchFamily="34" charset="-122"/>
+                <a:cs typeface="IBM Plex Mono" pitchFamily="34" charset="-120"/>
+              </a:rPr>
+              <a:t>:</a:t>
             </a:r>
             <a:endParaRPr lang="en-US" sz="1800" dirty="0"/>
           </a:p>
@@ -4925,8 +4976,8 @@
         </p:nvSpPr>
         <p:spPr>
           <a:xfrm>
-            <a:off x="11961614" y="7275762"/>
-            <a:ext cx="3630216" cy="381000"/>
+            <a:off x="12806362" y="7275762"/>
+            <a:ext cx="1833319" cy="381000"/>
           </a:xfrm>
           <a:prstGeom prst="roundRect">
             <a:avLst>
@@ -4969,7 +5020,7 @@
           </a:bodyPr>
           <a:lstStyle/>
           <a:p>
-            <a:pPr marL="0" indent="0" algn="l">
+            <a:pPr marL="0" indent="0" algn="ctr">
               <a:lnSpc>
                 <a:spcPct val="150000"/>
               </a:lnSpc>
@@ -5103,6 +5154,15 @@
               <a:buNone/>
             </a:pPr>
             <a:r>
+              <a:rPr lang="en-US" b="1" dirty="0">
+                <a:solidFill>
+                  <a:srgbClr val="1E3A5F"/>
+                </a:solidFill>
+                <a:latin typeface="IBM Plex Sans" pitchFamily="34" charset="0"/>
+              </a:rPr>
+              <a:t>Tratamento</a:t>
+            </a:r>
+            <a:r>
               <a:rPr lang="en-US" sz="1800" b="1" dirty="0">
                 <a:solidFill>
                   <a:srgbClr val="B8651A"/>
@@ -5111,7 +5171,7 @@
                 <a:ea typeface="IBM Plex Sans" pitchFamily="34" charset="-122"/>
                 <a:cs typeface="IBM Plex Sans" pitchFamily="34" charset="-120"/>
               </a:rPr>
-              <a:t>Tratamento </a:t>
+              <a:t> </a:t>
             </a:r>
             <a:r>
               <a:rPr lang="en-US" sz="1800" dirty="0">
@@ -5122,21 +5182,10 @@
                 <a:ea typeface="IBM Plex Sans" pitchFamily="34" charset="-122"/>
                 <a:cs typeface="IBM Plex Sans" pitchFamily="34" charset="-120"/>
               </a:rPr>
-              <a:t>— flag de </a:t>
-            </a:r>
-            <a:r>
-              <a:rPr lang="en-US" sz="1800" dirty="0">
-                <a:solidFill>
-                  <a:srgbClr val="15171A"/>
-                </a:solidFill>
-                <a:latin typeface="IBM Plex Mono" pitchFamily="34" charset="0"/>
-                <a:ea typeface="IBM Plex Mono" pitchFamily="34" charset="-122"/>
-                <a:cs typeface="IBM Plex Mono" pitchFamily="34" charset="-120"/>
-              </a:rPr>
-              <a:t>quarentena </a:t>
-            </a:r>
-            <a:r>
-              <a:rPr lang="en-US" sz="1800" dirty="0">
+              <a:t>— </a:t>
+            </a:r>
+            <a:r>
+              <a:rPr lang="en-US" dirty="0" err="1">
                 <a:solidFill>
                   <a:srgbClr val="15171A"/>
                 </a:solidFill>
@@ -5144,7 +5193,216 @@
                 <a:ea typeface="IBM Plex Sans" pitchFamily="34" charset="-122"/>
                 <a:cs typeface="IBM Plex Sans" pitchFamily="34" charset="-120"/>
               </a:rPr>
-              <a:t>; bruto preservado, decisão de descarte fica para o consumidor.</a:t>
+              <a:t>Descartei</a:t>
+            </a:r>
+            <a:r>
+              <a:rPr lang="en-US" dirty="0">
+                <a:solidFill>
+                  <a:srgbClr val="15171A"/>
+                </a:solidFill>
+                <a:latin typeface="IBM Plex Sans" pitchFamily="34" charset="0"/>
+                <a:ea typeface="IBM Plex Sans" pitchFamily="34" charset="-122"/>
+                <a:cs typeface="IBM Plex Sans" pitchFamily="34" charset="-120"/>
+              </a:rPr>
+              <a:t> a flag de </a:t>
+            </a:r>
+            <a:r>
+              <a:rPr lang="en-US" dirty="0" err="1">
+                <a:solidFill>
+                  <a:srgbClr val="15171A"/>
+                </a:solidFill>
+                <a:latin typeface="IBM Plex Sans" pitchFamily="34" charset="0"/>
+                <a:ea typeface="IBM Plex Sans" pitchFamily="34" charset="-122"/>
+                <a:cs typeface="IBM Plex Sans" pitchFamily="34" charset="-120"/>
+              </a:rPr>
+              <a:t>quarentena</a:t>
+            </a:r>
+            <a:r>
+              <a:rPr lang="en-US" dirty="0">
+                <a:solidFill>
+                  <a:srgbClr val="15171A"/>
+                </a:solidFill>
+                <a:latin typeface="IBM Plex Sans" pitchFamily="34" charset="0"/>
+                <a:ea typeface="IBM Plex Sans" pitchFamily="34" charset="-122"/>
+                <a:cs typeface="IBM Plex Sans" pitchFamily="34" charset="-120"/>
+              </a:rPr>
+              <a:t> </a:t>
+            </a:r>
+            <a:r>
+              <a:rPr lang="en-US" dirty="0" err="1">
+                <a:solidFill>
+                  <a:srgbClr val="15171A"/>
+                </a:solidFill>
+                <a:latin typeface="IBM Plex Sans" pitchFamily="34" charset="0"/>
+                <a:ea typeface="IBM Plex Sans" pitchFamily="34" charset="-122"/>
+                <a:cs typeface="IBM Plex Sans" pitchFamily="34" charset="-120"/>
+              </a:rPr>
+              <a:t>devido</a:t>
+            </a:r>
+            <a:r>
+              <a:rPr lang="en-US" dirty="0">
+                <a:solidFill>
+                  <a:srgbClr val="15171A"/>
+                </a:solidFill>
+                <a:latin typeface="IBM Plex Sans" pitchFamily="34" charset="0"/>
+                <a:ea typeface="IBM Plex Sans" pitchFamily="34" charset="-122"/>
+                <a:cs typeface="IBM Plex Sans" pitchFamily="34" charset="-120"/>
+              </a:rPr>
+              <a:t> a </a:t>
+            </a:r>
+            <a:r>
+              <a:rPr lang="en-US" dirty="0" err="1">
+                <a:solidFill>
+                  <a:srgbClr val="15171A"/>
+                </a:solidFill>
+                <a:latin typeface="IBM Plex Sans" pitchFamily="34" charset="0"/>
+                <a:ea typeface="IBM Plex Sans" pitchFamily="34" charset="-122"/>
+                <a:cs typeface="IBM Plex Sans" pitchFamily="34" charset="-120"/>
+              </a:rPr>
+              <a:t>falta</a:t>
+            </a:r>
+            <a:r>
+              <a:rPr lang="en-US" dirty="0">
+                <a:solidFill>
+                  <a:srgbClr val="15171A"/>
+                </a:solidFill>
+                <a:latin typeface="IBM Plex Sans" pitchFamily="34" charset="0"/>
+                <a:ea typeface="IBM Plex Sans" pitchFamily="34" charset="-122"/>
+                <a:cs typeface="IBM Plex Sans" pitchFamily="34" charset="-120"/>
+              </a:rPr>
+              <a:t> de </a:t>
+            </a:r>
+            <a:r>
+              <a:rPr lang="en-US" dirty="0" err="1">
+                <a:solidFill>
+                  <a:srgbClr val="15171A"/>
+                </a:solidFill>
+                <a:latin typeface="IBM Plex Sans" pitchFamily="34" charset="0"/>
+                <a:ea typeface="IBM Plex Sans" pitchFamily="34" charset="-122"/>
+                <a:cs typeface="IBM Plex Sans" pitchFamily="34" charset="-120"/>
+              </a:rPr>
+              <a:t>confiabilidade</a:t>
+            </a:r>
+            <a:r>
+              <a:rPr lang="en-US" dirty="0">
+                <a:solidFill>
+                  <a:srgbClr val="15171A"/>
+                </a:solidFill>
+                <a:latin typeface="IBM Plex Sans" pitchFamily="34" charset="0"/>
+                <a:ea typeface="IBM Plex Sans" pitchFamily="34" charset="-122"/>
+                <a:cs typeface="IBM Plex Sans" pitchFamily="34" charset="-120"/>
+              </a:rPr>
+              <a:t> </a:t>
+            </a:r>
+            <a:r>
+              <a:rPr lang="en-US" dirty="0" err="1">
+                <a:solidFill>
+                  <a:srgbClr val="15171A"/>
+                </a:solidFill>
+                <a:latin typeface="IBM Plex Sans" pitchFamily="34" charset="0"/>
+                <a:ea typeface="IBM Plex Sans" pitchFamily="34" charset="-122"/>
+                <a:cs typeface="IBM Plex Sans" pitchFamily="34" charset="-120"/>
+              </a:rPr>
+              <a:t>na</a:t>
+            </a:r>
+            <a:r>
+              <a:rPr lang="en-US" dirty="0">
+                <a:solidFill>
+                  <a:srgbClr val="15171A"/>
+                </a:solidFill>
+                <a:latin typeface="IBM Plex Sans" pitchFamily="34" charset="0"/>
+                <a:ea typeface="IBM Plex Sans" pitchFamily="34" charset="-122"/>
+                <a:cs typeface="IBM Plex Sans" pitchFamily="34" charset="-120"/>
+              </a:rPr>
+              <a:t> </a:t>
+            </a:r>
+            <a:r>
+              <a:rPr lang="en-US" dirty="0" err="1">
+                <a:solidFill>
+                  <a:srgbClr val="15171A"/>
+                </a:solidFill>
+                <a:latin typeface="IBM Plex Sans" pitchFamily="34" charset="0"/>
+                <a:ea typeface="IBM Plex Sans" pitchFamily="34" charset="-122"/>
+                <a:cs typeface="IBM Plex Sans" pitchFamily="34" charset="-120"/>
+              </a:rPr>
+              <a:t>coluna</a:t>
+            </a:r>
+            <a:r>
+              <a:rPr lang="en-US" dirty="0">
+                <a:solidFill>
+                  <a:srgbClr val="15171A"/>
+                </a:solidFill>
+                <a:latin typeface="IBM Plex Sans" pitchFamily="34" charset="0"/>
+                <a:ea typeface="IBM Plex Sans" pitchFamily="34" charset="-122"/>
+                <a:cs typeface="IBM Plex Sans" pitchFamily="34" charset="-120"/>
+              </a:rPr>
+              <a:t> </a:t>
+            </a:r>
+            <a:r>
+              <a:rPr lang="en-US" dirty="0" err="1">
+                <a:solidFill>
+                  <a:srgbClr val="15171A"/>
+                </a:solidFill>
+                <a:latin typeface="IBM Plex Sans" pitchFamily="34" charset="0"/>
+                <a:ea typeface="IBM Plex Sans" pitchFamily="34" charset="-122"/>
+                <a:cs typeface="IBM Plex Sans" pitchFamily="34" charset="-120"/>
+              </a:rPr>
+              <a:t>creation_time</a:t>
+            </a:r>
+            <a:r>
+              <a:rPr lang="en-US" dirty="0">
+                <a:solidFill>
+                  <a:srgbClr val="15171A"/>
+                </a:solidFill>
+                <a:latin typeface="IBM Plex Sans" pitchFamily="34" charset="0"/>
+                <a:ea typeface="IBM Plex Sans" pitchFamily="34" charset="-122"/>
+                <a:cs typeface="IBM Plex Sans" pitchFamily="34" charset="-120"/>
+              </a:rPr>
+              <a:t>, </a:t>
+            </a:r>
+            <a:r>
+              <a:rPr lang="en-US" dirty="0" err="1">
+                <a:solidFill>
+                  <a:srgbClr val="15171A"/>
+                </a:solidFill>
+                <a:latin typeface="IBM Plex Sans" pitchFamily="34" charset="0"/>
+                <a:ea typeface="IBM Plex Sans" pitchFamily="34" charset="-122"/>
+                <a:cs typeface="IBM Plex Sans" pitchFamily="34" charset="-120"/>
+              </a:rPr>
+              <a:t>verificado</a:t>
+            </a:r>
+            <a:r>
+              <a:rPr lang="en-US" dirty="0">
+                <a:solidFill>
+                  <a:srgbClr val="15171A"/>
+                </a:solidFill>
+                <a:latin typeface="IBM Plex Sans" pitchFamily="34" charset="0"/>
+                <a:ea typeface="IBM Plex Sans" pitchFamily="34" charset="-122"/>
+                <a:cs typeface="IBM Plex Sans" pitchFamily="34" charset="-120"/>
+              </a:rPr>
+              <a:t> no </a:t>
+            </a:r>
+            <a:r>
+              <a:rPr lang="en-US" dirty="0" err="1">
+                <a:solidFill>
+                  <a:srgbClr val="15171A"/>
+                </a:solidFill>
+                <a:latin typeface="IBM Plex Sans" pitchFamily="34" charset="0"/>
+                <a:ea typeface="IBM Plex Sans" pitchFamily="34" charset="-122"/>
+                <a:cs typeface="IBM Plex Sans" pitchFamily="34" charset="-120"/>
+              </a:rPr>
+              <a:t>problema</a:t>
+            </a:r>
+            <a:r>
+              <a:rPr lang="en-US" dirty="0">
+                <a:solidFill>
+                  <a:srgbClr val="15171A"/>
+                </a:solidFill>
+                <a:latin typeface="IBM Plex Sans" pitchFamily="34" charset="0"/>
+                <a:ea typeface="IBM Plex Sans" pitchFamily="34" charset="-122"/>
+                <a:cs typeface="IBM Plex Sans" pitchFamily="34" charset="-120"/>
+              </a:rPr>
+              <a:t> 2</a:t>
             </a:r>
             <a:endParaRPr lang="en-US" sz="1800" dirty="0"/>
           </a:p>
@@ -10992,7 +11250,18 @@
                 <a:ea typeface="IBM Plex Mono" pitchFamily="34" charset="-122"/>
                 <a:cs typeface="IBM Plex Mono" pitchFamily="34" charset="-120"/>
               </a:rPr>
-              <a:t>02 · DATA SKEW</a:t>
+              <a:t>02 · DATA </a:t>
+            </a:r>
+            <a:r>
+              <a:rPr lang="en-US" kern="0" spc="144" dirty="0">
+                <a:solidFill>
+                  <a:srgbClr val="1E3A5F"/>
+                </a:solidFill>
+                <a:latin typeface="IBM Plex Mono" pitchFamily="34" charset="0"/>
+                <a:ea typeface="IBM Plex Mono" pitchFamily="34" charset="-122"/>
+                <a:cs typeface="IBM Plex Mono" pitchFamily="34" charset="-120"/>
+              </a:rPr>
+              <a:t>QUALITY TEST </a:t>
             </a:r>
             <a:endParaRPr lang="en-US" sz="1800" dirty="0"/>
           </a:p>
@@ -11000,14 +11269,14 @@
       </p:sp>
       <p:sp>
         <p:nvSpPr>
-          <p:cNvPr id="12" name="Text 10"/>
-          <p:cNvSpPr/>
-          <p:nvPr/>
-        </p:nvSpPr>
-        <p:spPr>
-          <a:xfrm>
-            <a:off x="6753225" y="3671739"/>
-            <a:ext cx="4924997" cy="678061"/>
+          <p:cNvPr id="13" name="Text 11"/>
+          <p:cNvSpPr/>
+          <p:nvPr/>
+        </p:nvSpPr>
+        <p:spPr>
+          <a:xfrm>
+            <a:off x="6681501" y="3661772"/>
+            <a:ext cx="4924997" cy="2288267"/>
           </a:xfrm>
           <a:prstGeom prst="rect">
             <a:avLst/>
@@ -11017,171 +11286,141 @@
         </p:spPr>
         <p:txBody>
           <a:bodyPr wrap="square" lIns="25400" tIns="25400" rIns="25400" bIns="25400" rtlCol="0" anchor="t">
-            <a:normAutofit fontScale="92500" lnSpcReduction="10000"/>
-          </a:bodyPr>
-          <a:lstStyle/>
-          <a:p>
-            <a:pPr marL="0" indent="0" algn="l">
-              <a:lnSpc>
-                <a:spcPct val="140000"/>
-              </a:lnSpc>
-              <a:buNone/>
-            </a:pPr>
-            <a:r>
-              <a:rPr lang="en-US" sz="3600" kern="0" spc="-36" dirty="0">
-                <a:solidFill>
-                  <a:srgbClr val="15171A"/>
-                </a:solidFill>
-                <a:latin typeface="IBM Plex Mono" pitchFamily="34" charset="0"/>
-                <a:ea typeface="IBM Plex Mono" pitchFamily="34" charset="-122"/>
-                <a:cs typeface="IBM Plex Mono" pitchFamily="34" charset="-120"/>
-              </a:rPr>
-              <a:t>~140</a:t>
-            </a:r>
-            <a:r>
-              <a:rPr lang="en-US" sz="3600" kern="0" spc="-36" dirty="0">
-                <a:solidFill>
-                  <a:srgbClr val="B8651A"/>
-                </a:solidFill>
-                <a:latin typeface="IBM Plex Mono" pitchFamily="34" charset="0"/>
-                <a:ea typeface="IBM Plex Mono" pitchFamily="34" charset="-122"/>
-                <a:cs typeface="IBM Plex Mono" pitchFamily="34" charset="-120"/>
-              </a:rPr>
-              <a:t>×</a:t>
-            </a:r>
-            <a:endParaRPr lang="en-US" sz="3600" dirty="0"/>
-          </a:p>
-        </p:txBody>
-      </p:sp>
-      <p:sp>
-        <p:nvSpPr>
-          <p:cNvPr id="13" name="Text 11"/>
-          <p:cNvSpPr/>
-          <p:nvPr/>
-        </p:nvSpPr>
-        <p:spPr>
-          <a:xfrm>
-            <a:off x="6753225" y="4368850"/>
-            <a:ext cx="4924997" cy="657225"/>
-          </a:xfrm>
-          <a:prstGeom prst="rect">
-            <a:avLst/>
-          </a:prstGeom>
-          <a:noFill/>
-          <a:ln/>
-        </p:spPr>
-        <p:txBody>
-          <a:bodyPr wrap="square" lIns="25400" tIns="25400" rIns="25400" bIns="25400" rtlCol="0" anchor="t">
-            <a:normAutofit fontScale="92500" lnSpcReduction="20000"/>
-          </a:bodyPr>
-          <a:lstStyle/>
-          <a:p>
-            <a:pPr marL="0" indent="0" algn="l">
+            <a:normAutofit/>
+          </a:bodyPr>
+          <a:lstStyle/>
+          <a:p>
+            <a:pPr>
               <a:lnSpc>
                 <a:spcPct val="125000"/>
               </a:lnSpc>
-              <a:buNone/>
-            </a:pPr>
-            <a:r>
-              <a:rPr lang="en-US" sz="1950" b="1" kern="0" spc="-19" dirty="0">
-                <a:solidFill>
-                  <a:srgbClr val="15171A"/>
+            </a:pPr>
+            <a:r>
+              <a:rPr lang="pt-BR" sz="1700" b="1" dirty="0"/>
+              <a:t>Validações como contrato, não checagem manual</a:t>
+            </a:r>
+            <a:r>
+              <a:rPr lang="pt-BR" sz="1700" dirty="0"/>
+              <a:t> </a:t>
+            </a:r>
+            <a:endParaRPr lang="pt-BR" sz="2000" dirty="0">
+              <a:solidFill>
+                <a:srgbClr val="3A3D44"/>
+              </a:solidFill>
+              <a:latin typeface="IBM Plex Sans" pitchFamily="34" charset="0"/>
+            </a:endParaRPr>
+          </a:p>
+          <a:p>
+            <a:pPr>
+              <a:lnSpc>
+                <a:spcPct val="125000"/>
+              </a:lnSpc>
+            </a:pPr>
+            <a:r>
+              <a:rPr lang="pt-BR" sz="1500" dirty="0">
+                <a:solidFill>
+                  <a:srgbClr val="3A3D44"/>
                 </a:solidFill>
                 <a:latin typeface="IBM Plex Sans" pitchFamily="34" charset="0"/>
-                <a:ea typeface="IBM Plex Sans" pitchFamily="34" charset="-122"/>
-                <a:cs typeface="IBM Plex Sans" pitchFamily="34" charset="-120"/>
-              </a:rPr>
-              <a:t>Volume por device varia em duas ordens de grandeza</a:t>
-            </a:r>
-            <a:endParaRPr lang="en-US" sz="1950" dirty="0"/>
-          </a:p>
-        </p:txBody>
-      </p:sp>
-      <p:sp>
-        <p:nvSpPr>
-          <p:cNvPr id="14" name="Text 12"/>
-          <p:cNvSpPr/>
-          <p:nvPr/>
-        </p:nvSpPr>
-        <p:spPr>
-          <a:xfrm>
-            <a:off x="6753225" y="5121325"/>
-            <a:ext cx="4924997" cy="624780"/>
-          </a:xfrm>
-          <a:prstGeom prst="rect">
-            <a:avLst/>
-          </a:prstGeom>
-          <a:noFill/>
-          <a:ln/>
-        </p:spPr>
-        <p:txBody>
-          <a:bodyPr wrap="square" lIns="25400" tIns="25400" rIns="25400" bIns="25400" rtlCol="0" anchor="t">
-            <a:normAutofit fontScale="92500" lnSpcReduction="10000"/>
-          </a:bodyPr>
-          <a:lstStyle/>
-          <a:p>
-            <a:pPr marL="0" indent="0" algn="l">
-              <a:lnSpc>
-                <a:spcPct val="140000"/>
-              </a:lnSpc>
-              <a:buNone/>
-            </a:pPr>
-            <a:r>
-              <a:rPr lang="en-US" sz="1650" dirty="0">
+              </a:rPr>
+              <a:t>As regras que apliquei no notebook ("</a:t>
+            </a:r>
+            <a:r>
+              <a:rPr lang="pt-BR" sz="1500" dirty="0" err="1">
                 <a:solidFill>
                   <a:srgbClr val="3A3D44"/>
                 </a:solidFill>
                 <a:latin typeface="IBM Plex Sans" pitchFamily="34" charset="0"/>
-                <a:ea typeface="IBM Plex Sans" pitchFamily="34" charset="-122"/>
-                <a:cs typeface="IBM Plex Sans" pitchFamily="34" charset="-120"/>
-              </a:rPr>
-              <a:t>Skew real, não teórico. Em produção: </a:t>
-            </a:r>
-            <a:r>
-              <a:rPr lang="en-US" sz="1650" dirty="0">
+              </a:rPr>
+              <a:t>null</a:t>
+            </a:r>
+            <a:r>
+              <a:rPr lang="pt-BR" sz="1500" dirty="0">
                 <a:solidFill>
                   <a:srgbClr val="3A3D44"/>
                 </a:solidFill>
-                <a:latin typeface="IBM Plex Mono" pitchFamily="34" charset="0"/>
-                <a:ea typeface="IBM Plex Mono" pitchFamily="34" charset="-122"/>
-                <a:cs typeface="IBM Plex Mono" pitchFamily="34" charset="-120"/>
-              </a:rPr>
-              <a:t>AQE </a:t>
-            </a:r>
-            <a:r>
-              <a:rPr lang="en-US" sz="1650" dirty="0">
+                <a:latin typeface="IBM Plex Sans" pitchFamily="34" charset="0"/>
+              </a:rPr>
+              <a:t>"→NULL, de-</a:t>
+            </a:r>
+            <a:r>
+              <a:rPr lang="pt-BR" sz="1500" dirty="0" err="1">
                 <a:solidFill>
                   <a:srgbClr val="3A3D44"/>
                 </a:solidFill>
                 <a:latin typeface="IBM Plex Sans" pitchFamily="34" charset="0"/>
-                <a:ea typeface="IBM Plex Sans" pitchFamily="34" charset="-122"/>
-                <a:cs typeface="IBM Plex Sans" pitchFamily="34" charset="-120"/>
-              </a:rPr>
-              <a:t>ligado, </a:t>
-            </a:r>
-            <a:r>
-              <a:rPr lang="en-US" sz="1650" dirty="0">
+              </a:rPr>
+              <a:t>dup</a:t>
+            </a:r>
+            <a:r>
+              <a:rPr lang="pt-BR" sz="1500" dirty="0">
                 <a:solidFill>
                   <a:srgbClr val="3A3D44"/>
                 </a:solidFill>
-                <a:latin typeface="IBM Plex Mono" pitchFamily="34" charset="0"/>
-                <a:ea typeface="IBM Plex Mono" pitchFamily="34" charset="-122"/>
-                <a:cs typeface="IBM Plex Mono" pitchFamily="34" charset="-120"/>
-              </a:rPr>
-              <a:t>salting </a:t>
-            </a:r>
-            <a:r>
-              <a:rPr lang="en-US" sz="1650" dirty="0">
+                <a:latin typeface="IBM Plex Sans" pitchFamily="34" charset="0"/>
+              </a:rPr>
+              <a:t> por chave, magnitude do </a:t>
+            </a:r>
+            <a:r>
+              <a:rPr lang="pt-BR" sz="1500" dirty="0" err="1">
                 <a:solidFill>
                   <a:srgbClr val="3A3D44"/>
                 </a:solidFill>
                 <a:latin typeface="IBM Plex Sans" pitchFamily="34" charset="0"/>
-                <a:ea typeface="IBM Plex Sans" pitchFamily="34" charset="-122"/>
-                <a:cs typeface="IBM Plex Sans" pitchFamily="34" charset="-120"/>
-              </a:rPr>
-              <a:t>em joins por device se necessário.</a:t>
-            </a:r>
-            <a:endParaRPr lang="en-US" sz="1650" dirty="0"/>
+              </a:rPr>
+              <a:t>Creation_Time</a:t>
+            </a:r>
+            <a:r>
+              <a:rPr lang="pt-BR" sz="1500" dirty="0">
+                <a:solidFill>
+                  <a:srgbClr val="3A3D44"/>
+                </a:solidFill>
+                <a:latin typeface="IBM Plex Sans" pitchFamily="34" charset="0"/>
+              </a:rPr>
+              <a:t>) viram </a:t>
+            </a:r>
+            <a:r>
+              <a:rPr lang="pt-BR" sz="1500" dirty="0" err="1">
+                <a:solidFill>
+                  <a:srgbClr val="3A3D44"/>
+                </a:solidFill>
+                <a:latin typeface="IBM Plex Sans" pitchFamily="34" charset="0"/>
+              </a:rPr>
+              <a:t>expectations</a:t>
+            </a:r>
+            <a:r>
+              <a:rPr lang="pt-BR" sz="1500" dirty="0">
+                <a:solidFill>
+                  <a:srgbClr val="3A3D44"/>
+                </a:solidFill>
+                <a:latin typeface="IBM Plex Sans" pitchFamily="34" charset="0"/>
+              </a:rPr>
+              <a:t> </a:t>
+            </a:r>
+            <a:r>
+              <a:rPr lang="pt-BR" sz="1500" dirty="0" err="1">
+                <a:solidFill>
+                  <a:srgbClr val="3A3D44"/>
+                </a:solidFill>
+                <a:latin typeface="IBM Plex Sans" pitchFamily="34" charset="0"/>
+              </a:rPr>
+              <a:t>versionadas</a:t>
+            </a:r>
+            <a:r>
+              <a:rPr lang="pt-BR" sz="1500" dirty="0">
+                <a:solidFill>
+                  <a:srgbClr val="3A3D44"/>
+                </a:solidFill>
+                <a:latin typeface="IBM Plex Sans" pitchFamily="34" charset="0"/>
+              </a:rPr>
+              <a:t> que falham o pipeline cedo, antes da camada analítica.</a:t>
+            </a:r>
+            <a:endParaRPr lang="en-US" sz="1500" dirty="0">
+              <a:solidFill>
+                <a:srgbClr val="3A3D44"/>
+              </a:solidFill>
+              <a:latin typeface="IBM Plex Sans" pitchFamily="34" charset="0"/>
+            </a:endParaRPr>
           </a:p>
         </p:txBody>
       </p:sp>
@@ -11390,89 +11629,81 @@
               </a:rPr>
               <a:t>; </a:t>
             </a:r>
-            <a:endParaRPr lang="en-US" sz="1650" dirty="0"/>
-          </a:p>
-        </p:txBody>
-      </p:sp>
-      <p:sp>
-        <p:nvSpPr>
-          <p:cNvPr id="19" name="Shape 17"/>
-          <p:cNvSpPr/>
-          <p:nvPr/>
-        </p:nvSpPr>
-        <p:spPr>
-          <a:xfrm>
-            <a:off x="914400" y="8033445"/>
-            <a:ext cx="16459200" cy="9525"/>
-          </a:xfrm>
-          <a:prstGeom prst="rect">
-            <a:avLst/>
-          </a:prstGeom>
-          <a:solidFill>
-            <a:srgbClr val="D9D4C5"/>
-          </a:solidFill>
-          <a:ln/>
-        </p:spPr>
-        <p:txBody>
-          <a:bodyPr/>
-          <a:lstStyle/>
-          <a:p>
-            <a:endParaRPr lang="pt-BR"/>
-          </a:p>
-        </p:txBody>
-      </p:sp>
-      <p:sp>
-        <p:nvSpPr>
-          <p:cNvPr id="20" name="Text 18"/>
-          <p:cNvSpPr/>
-          <p:nvPr/>
-        </p:nvSpPr>
-        <p:spPr>
-          <a:xfrm>
-            <a:off x="914400" y="8538270"/>
-            <a:ext cx="11772900" cy="758130"/>
-          </a:xfrm>
-          <a:prstGeom prst="rect">
-            <a:avLst/>
-          </a:prstGeom>
-          <a:noFill/>
-          <a:ln/>
-        </p:spPr>
-        <p:txBody>
-          <a:bodyPr wrap="square" lIns="25400" tIns="25400" rIns="25400" bIns="25400" rtlCol="0" anchor="t">
-            <a:normAutofit fontScale="92500" lnSpcReduction="10000"/>
-          </a:bodyPr>
-          <a:lstStyle/>
+          </a:p>
           <a:p>
             <a:pPr marL="0" indent="0" algn="l">
               <a:lnSpc>
-                <a:spcPct val="135000"/>
-              </a:lnSpc>
-              <a:buNone/>
-            </a:pPr>
-            <a:r>
-              <a:rPr lang="en-US" sz="2100" b="1" dirty="0">
-                <a:solidFill>
-                  <a:srgbClr val="15171A"/>
+                <a:spcPct val="140000"/>
+              </a:lnSpc>
+              <a:buNone/>
+            </a:pPr>
+            <a:r>
+              <a:rPr lang="en-US" sz="1650" dirty="0">
+                <a:solidFill>
+                  <a:srgbClr val="F6F4EE">
+                    <a:alpha val="72000"/>
+                  </a:srgbClr>
                 </a:solidFill>
                 <a:latin typeface="IBM Plex Sans" pitchFamily="34" charset="0"/>
                 <a:ea typeface="IBM Plex Sans" pitchFamily="34" charset="-122"/>
                 <a:cs typeface="IBM Plex Sans" pitchFamily="34" charset="-120"/>
               </a:rPr>
-              <a:t>Fechamento. </a:t>
-            </a:r>
-            <a:r>
-              <a:rPr lang="en-US" sz="2100" dirty="0">
-                <a:solidFill>
-                  <a:srgbClr val="15171A"/>
+              <a:t>Z-Order </a:t>
+            </a:r>
+            <a:r>
+              <a:rPr lang="en-US" sz="1650" dirty="0" err="1">
+                <a:solidFill>
+                  <a:srgbClr val="F6F4EE">
+                    <a:alpha val="72000"/>
+                  </a:srgbClr>
                 </a:solidFill>
                 <a:latin typeface="IBM Plex Sans" pitchFamily="34" charset="0"/>
                 <a:ea typeface="IBM Plex Sans" pitchFamily="34" charset="-122"/>
                 <a:cs typeface="IBM Plex Sans" pitchFamily="34" charset="-120"/>
               </a:rPr>
-              <a:t>Pipeline reprodutível, decisões justificadas por evidência no dado, problemas tratados sem descartar o bruto.</a:t>
-            </a:r>
-            <a:endParaRPr lang="en-US" sz="2100" dirty="0"/>
+              <a:t>por</a:t>
+            </a:r>
+            <a:r>
+              <a:rPr lang="en-US" sz="1650" dirty="0">
+                <a:solidFill>
+                  <a:srgbClr val="F6F4EE">
+                    <a:alpha val="72000"/>
+                  </a:srgbClr>
+                </a:solidFill>
+                <a:latin typeface="IBM Plex Sans" pitchFamily="34" charset="0"/>
+                <a:ea typeface="IBM Plex Sans" pitchFamily="34" charset="-122"/>
+                <a:cs typeface="IBM Plex Sans" pitchFamily="34" charset="-120"/>
+              </a:rPr>
+              <a:t> user, device </a:t>
+            </a:r>
+            <a:endParaRPr lang="en-US" sz="1650" dirty="0"/>
+          </a:p>
+        </p:txBody>
+      </p:sp>
+      <p:sp>
+        <p:nvSpPr>
+          <p:cNvPr id="19" name="Shape 17"/>
+          <p:cNvSpPr/>
+          <p:nvPr/>
+        </p:nvSpPr>
+        <p:spPr>
+          <a:xfrm>
+            <a:off x="914400" y="8033445"/>
+            <a:ext cx="16459200" cy="9525"/>
+          </a:xfrm>
+          <a:prstGeom prst="rect">
+            <a:avLst/>
+          </a:prstGeom>
+          <a:solidFill>
+            <a:srgbClr val="D9D4C5"/>
+          </a:solidFill>
+          <a:ln/>
+        </p:spPr>
+        <p:txBody>
+          <a:bodyPr/>
+          <a:lstStyle/>
+          <a:p>
+            <a:endParaRPr lang="pt-BR"/>
           </a:p>
         </p:txBody>
       </p:sp>

</xml_diff>